<commit_message>
Preserve ASK migration and current research updates before MGP-6 v4.3 integration
</commit_message>
<xml_diff>
--- a/presentation/defense_en.pptx
+++ b/presentation/defense_en.pptx
@@ -2247,7 +2247,7 @@
           <a:lstStyle xmlns:a="http://schemas.openxmlformats.org/drawingml/2006/main"/>
           <a:p xmlns:a="http://schemas.openxmlformats.org/drawingml/2006/main">
             <a:r>
-              <a:t>Point to the repository structure if implementation questions arise: src/ksa contains the library; scripts contain frozen runners and verification; benchmarks contain the redistributable MGP-6 diagnostic; artifacts and reports contain ledgers and audit outputs.</a:t>
+              <a:t>Point to the repository structure if implementation questions arise: src/ask contains the library; scripts contain frozen runners and verification; benchmarks contain the redistributable MGP-6 diagnostic; artifacts and reports contain ledgers and audit outputs.</a:t>
             </a:r>
           </a:p>
         </p:txBody>
@@ -3301,10 +3301,10 @@
                 <c:v>Zero-shot</c:v>
               </c:pt>
               <c:pt idx="5">
-                <c:v>LLM KSA</c:v>
+                <c:v>LLM ASK</c:v>
               </c:pt>
               <c:pt idx="6">
-                <c:v>Rule KSA</c:v>
+                <c:v>Rule ASK</c:v>
               </c:pt>
             </c:strLit>
           </c:cat>
@@ -3956,7 +3956,7 @@
                 <a:ea typeface="Arial"/>
                 <a:cs typeface="Arial"/>
               </a:rPr>
-              <a:t>Ali Mohammadi · KSA Memory Governance · 2026</a:t>
+              <a:t>Ali Mohammadi · ASK Memory Governance · 2026</a:t>
             </a:r>
           </a:p>
         </p:txBody>
@@ -4931,7 +4931,7 @@
                 <a:ea typeface="Arial"/>
                 <a:cs typeface="Arial"/>
               </a:rPr>
-              <a:t>Rule KSA vs unstructured zero-shot decision baseline. Holm-adjusted p = 1.6×10⁻⁵.</a:t>
+              <a:t>Rule ASK vs unstructured zero-shot decision baseline. Holm-adjusted p = 1.6×10⁻⁵.</a:t>
             </a:r>
           </a:p>
           <a:p xmlns:a="http://schemas.openxmlformats.org/drawingml/2006/main">
@@ -6065,7 +6065,7 @@
                           <a:ea typeface="Arial"/>
                           <a:cs typeface="Arial"/>
                         </a:rPr>
-                        <a:t>Full KSA</a:t>
+                        <a:t>Full ASK</a:t>
                       </a:r>
                     </a:p>
                   </a:txBody>
@@ -6924,7 +6924,7 @@
                 <a:ea typeface="Arial"/>
                 <a:cs typeface="Arial"/>
               </a:rPr>
-              <a:t>These adapters do not expose KSA’s native action semantics. Report both mappings; do not read the favourable mapping as a capability estimate.</a:t>
+              <a:t>These adapters do not expose ASK’s native action semantics. Report both mappings; do not read the favourable mapping as a capability estimate.</a:t>
             </a:r>
           </a:p>
           <a:p xmlns:a="http://schemas.openxmlformats.org/drawingml/2006/main">
@@ -9410,7 +9410,7 @@
                 <a:ea typeface="Arial"/>
                 <a:cs typeface="Arial"/>
               </a:rPr>
-              <a:t>Rule KSA</a:t>
+              <a:t>Rule ASK</a:t>
             </a:r>
           </a:p>
         </p:txBody>
@@ -12800,7 +12800,7 @@
                           <a:ea typeface="Arial"/>
                           <a:cs typeface="Arial"/>
                         </a:rPr>
-                        <a:t>Rule KSA</a:t>
+                        <a:t>Rule ASK</a:t>
                       </a:r>
                     </a:p>
                   </a:txBody>
@@ -12902,7 +12902,7 @@
                           <a:ea typeface="Arial"/>
                           <a:cs typeface="Arial"/>
                         </a:rPr>
-                        <a:t>LLM KSA</a:t>
+                        <a:t>LLM ASK</a:t>
                       </a:r>
                     </a:p>
                   </a:txBody>
@@ -13435,7 +13435,7 @@
                           <a:ea typeface="Arial"/>
                           <a:cs typeface="Arial"/>
                         </a:rPr>
-                        <a:t>Rule vs LLM KSA</a:t>
+                        <a:t>Rule vs LLM ASK</a:t>
                       </a:r>
                     </a:p>
                   </a:txBody>
@@ -16363,7 +16363,7 @@
                           <a:ea typeface="Arial"/>
                           <a:cs typeface="Arial"/>
                         </a:rPr>
-                        <a:t>No native KSA abstain semantics</a:t>
+                        <a:t>No native ASK abstain semantics</a:t>
                       </a:r>
                     </a:p>
                   </a:txBody>
@@ -16972,7 +16972,7 @@
                           <a:ea typeface="Arial"/>
                           <a:cs typeface="Arial"/>
                         </a:rPr>
-                        <a:t>Difference from evaluated KSA combination</a:t>
+                        <a:t>Difference from evaluated ASK combination</a:t>
                       </a:r>
                     </a:p>
                   </a:txBody>
@@ -18961,7 +18961,7 @@
                           <a:ea typeface="Arial"/>
                           <a:cs typeface="Arial"/>
                         </a:rPr>
-                        <a:t>Rule KSA</a:t>
+                        <a:t>Rule ASK</a:t>
                       </a:r>
                     </a:p>
                   </a:txBody>
@@ -19088,7 +19088,7 @@
                           <a:ea typeface="Arial"/>
                           <a:cs typeface="Arial"/>
                         </a:rPr>
-                        <a:t>LLM KSA</a:t>
+                        <a:t>LLM ASK</a:t>
                       </a:r>
                     </a:p>
                   </a:txBody>
@@ -20755,7 +20755,7 @@
                 <a:ea typeface="Arial"/>
                 <a:cs typeface="Arial"/>
               </a:rPr>
-              <a:t>Source: src/ksa; scripts/evaluation; tests; docs/audit/BEHAVIOR_TO_CODE_TRACEABILITY.md</a:t>
+              <a:t>Source: src/ask; scripts/evaluation; tests; docs/audit/BEHAVIOR_TO_CODE_TRACEABILITY.md</a:t>
             </a:r>
           </a:p>
         </p:txBody>
@@ -22066,7 +22066,7 @@
                 <a:ea typeface="Arial"/>
                 <a:cs typeface="Arial"/>
               </a:rPr>
-              <a:t>Source: thesis §3–4; src/ksa/memory/operations.py</a:t>
+              <a:t>Source: thesis §3–4; src/ask/memory/operations.py</a:t>
             </a:r>
           </a:p>
         </p:txBody>
@@ -22153,7 +22153,7 @@
                 <a:ea typeface="Arial"/>
                 <a:cs typeface="Arial"/>
               </a:rPr>
-              <a:t>KSA places model proposals inside a deterministic governance boundary</a:t>
+              <a:t>ASK places model proposals inside a deterministic governance boundary</a:t>
             </a:r>
           </a:p>
         </p:txBody>
@@ -23184,7 +23184,7 @@
                 <a:ea typeface="Arial"/>
                 <a:cs typeface="Arial"/>
               </a:rPr>
-              <a:t>Source: src/ksa/pipeline/orchestrator.py; docs/figures/figure_07_ksa_controller_architecture.svg</a:t>
+              <a:t>Source: src/ask/pipeline/orchestrator.py; docs/figures/figure_07_ask_controller_architecture.svg</a:t>
             </a:r>
           </a:p>
         </p:txBody>
@@ -23887,7 +23887,7 @@
                 <a:ea typeface="Arial"/>
                 <a:cs typeface="Arial"/>
               </a:rPr>
-              <a:t>Source: src/ksa/controller/policy.py and scoring.py</a:t>
+              <a:t>Source: src/ask/controller/policy.py and scoring.py</a:t>
             </a:r>
           </a:p>
         </p:txBody>
@@ -24736,7 +24736,7 @@
                 <a:ea typeface="Arial"/>
                 <a:cs typeface="Arial"/>
               </a:rPr>
-              <a:t>Source: src/ksa/memory/operations.py; lineage-integrity metric</a:t>
+              <a:t>Source: src/ask/memory/operations.py; lineage-integrity metric</a:t>
             </a:r>
           </a:p>
         </p:txBody>

</xml_diff>